<commit_message>
Update slides to the deployed state and add the expiry dates to the README
</commit_message>
<xml_diff>
--- a/Model-Review-Board.pptx
+++ b/Model-Review-Board.pptx
@@ -116,12 +116,12 @@
   <p:extLst>
     <p:ext uri="{521415D9-36F7-43E2-AB2F-B90AF26B5E84}">
       <p14:sectionLst xmlns:p14="http://schemas.microsoft.com/office/powerpoint/2010/main">
-        <p14:section name="Introduction" id="{c63a5a8c-ce9e-842b-de32-250b6508f92e}">
+        <p14:section name="Introduction" id="{ba45e60c-ad51-c021-fa17-dbd96808faf9}">
           <p14:sldIdLst>
             <p14:sldId id="256"/>
           </p14:sldIdLst>
         </p14:section>
-        <p14:section name="The app" id="{97fa2d7c-2d2b-7d04-1554-f5fb5cfb4280}">
+        <p14:section name="The app" id="{edba4941-90b7-0832-08fa-a59af44acd26}">
           <p14:sldIdLst>
             <p14:sldId id="257"/>
             <p14:sldId id="258"/>
@@ -131,12 +131,12 @@
             <p14:sldId id="262"/>
           </p14:sldIdLst>
         </p14:section>
-        <p14:section name="Quality" id="{2426eb25-c6f5-2632-90b4-32933ed6e062}">
+        <p14:section name="Quality" id="{cdd1d993-41e9-6305-3a21-1e794a0831d7}">
           <p14:sldIdLst>
             <p14:sldId id="263"/>
           </p14:sldIdLst>
         </p14:section>
-        <p14:section name="Deployment" id="{06677dac-e4ce-30b3-4c23-f2153e8fb759}">
+        <p14:section name="Deployment" id="{102815b5-f7b2-8d9d-be0a-a1b2387bf21d}">
           <p14:sldIdLst>
             <p14:sldId id="264"/>
             <p14:sldId id="265"/>
@@ -934,7 +934,7 @@
           <a:p>
             <a:r>
               <a:rPr lang="en-US" dirty="0"/>
-              <a:t>The reflection from the deployment notes. SQLite is for development. Before real review data, the app needs logins and access control. The deployment itself is still open.</a:t>
+              <a:t>The reflection from the deployment notes. SQLite is for development. Before real review data, the app needs logins and access control. The deployment is done on the free plan, with evidence in the repository, and it is planned to be removed around 24 November.</a:t>
             </a:r>
             <a:endParaRPr lang="en-US" dirty="0"/>
           </a:p>
@@ -1638,7 +1638,7 @@
           <a:p>
             <a:r>
               <a:rPr lang="en-US" dirty="0"/>
-              <a:t>The Blueprint is written and guarded by tests. The app is not deployed yet, so this slide says so plainly. The free plan limits explain why the data lives in PostgreSQL and not in a file.</a:t>
+              <a:t>The Blueprint created the service and the database on the free plan. A review made on the public app survived a redeploy. After 15 minutes of silence the service went to sleep, and the first load took 44.49 seconds. The app stays online until about 24 November 2026, then it is removed.</a:t>
             </a:r>
             <a:endParaRPr lang="en-US" dirty="0"/>
           </a:p>
@@ -2908,7 +2908,7 @@
                   <a:schemeClr val="bg2"/>
                 </a:solidFill>
               </a:rPr>
-              <a:t>Why a SQLite file is not enough on Render, the one change before sensitive data, and what is still open.</a:t>
+              <a:t>Why a SQLite file is not enough on Render, what the deployment showed, and the one change before sensitive data.</a:t>
             </a:r>
             <a:endParaRPr lang="en-US" sz="1600" dirty="0"/>
           </a:p>
@@ -3286,7 +3286,7 @@
                   <a:schemeClr val="bg1"/>
                 </a:solidFill>
               </a:rPr>
-              <a:t>Still open</a:t>
+              <a:t>What we saw</a:t>
             </a:r>
             <a:endParaRPr lang="en-US" sz="1600" dirty="0"/>
           </a:p>
@@ -3322,7 +3322,7 @@
                   <a:schemeClr val="bg1"/>
                 </a:solidFill>
               </a:rPr>
-              <a:t>The real deployment: a public URL, a review that survives a restart, and the cleanup.</a:t>
+              <a:t>A review survived a redeploy. The first load after sleep took 44.49 seconds. Removal is planned for about 24 November.</a:t>
             </a:r>
             <a:endParaRPr lang="en-US" sz="1400" dirty="0"/>
           </a:p>
@@ -3361,7 +3361,7 @@
                 <a:ea typeface="Cambria" pitchFamily="34" charset="-122"/>
                 <a:cs typeface="Cambria" pitchFamily="34" charset="-120"/>
               </a:rPr>
-              <a:t>Prepared, tested and ready for the Render free plan</a:t>
+              <a:t>Built, tested and deployed on Render's free plan</a:t>
             </a:r>
             <a:endParaRPr lang="en-US" sz="2000" dirty="0"/>
           </a:p>
@@ -8405,7 +8405,7 @@
                   <a:schemeClr val="accent5"/>
                 </a:solidFill>
               </a:rPr>
-              <a:t>A Render Blueprint creates the web service and the database. Both are on the free plan, and no secret is written in the file.</a:t>
+              <a:t>A Render Blueprint created the web service and the database. Both are on the free plan, the app is live, and the evidence is in the repository.</a:t>
             </a:r>
             <a:endParaRPr lang="en-US" sz="1600" dirty="0"/>
           </a:p>
@@ -8507,7 +8507,7 @@
                   <a:schemeClr val="tx2"/>
                 </a:solidFill>
               </a:rPr>
-              <a:t>Two free resources</a:t>
+              <a:t>Live on free plans</a:t>
             </a:r>
             <a:endParaRPr lang="en-US" sz="1600" dirty="0"/>
           </a:p>
@@ -8543,7 +8543,7 @@
                   <a:schemeClr val="tx1"/>
                 </a:solidFill>
               </a:rPr>
-              <a:t>A Python web service and a PostgreSQL database. Both plans are written as free.</a:t>
+              <a:t>A Python web service and a PostgreSQL database, both Free. No card was added.</a:t>
             </a:r>
             <a:endParaRPr lang="en-US" sz="1400" dirty="0"/>
           </a:p>
@@ -8645,7 +8645,7 @@
                   <a:schemeClr val="tx2"/>
                 </a:solidFill>
               </a:rPr>
-              <a:t>No secret in the file</a:t>
+              <a:t>It survived a redeploy</a:t>
             </a:r>
             <a:endParaRPr lang="en-US" sz="1600" dirty="0"/>
           </a:p>
@@ -8681,7 +8681,7 @@
                   <a:schemeClr val="tx1"/>
                 </a:solidFill>
               </a:rPr>
-              <a:t>Render wires DATABASE_URL from the database and generates the secret key.</a:t>
+              <a:t>A review made on the public app was still there afterwards, because it lives in PostgreSQL.</a:t>
             </a:r>
             <a:endParaRPr lang="en-US" sz="1400" dirty="0"/>
           </a:p>
@@ -8783,7 +8783,7 @@
                   <a:schemeClr val="tx2"/>
                 </a:solidFill>
               </a:rPr>
-              <a:t>Free service limits</a:t>
+              <a:t>A slow first load</a:t>
             </a:r>
             <a:endParaRPr lang="en-US" sz="1600" dirty="0"/>
           </a:p>
@@ -8819,7 +8819,7 @@
                   <a:schemeClr val="tx1"/>
                 </a:solidFill>
               </a:rPr>
-              <a:t>It spins down after 15 minutes without traffic, and its files are lost on a redeploy.</a:t>
+              <a:t>After 15 minutes of silence the service sleeps. The first load took 44.49 seconds.</a:t>
             </a:r>
             <a:endParaRPr lang="en-US" sz="1400" dirty="0"/>
           </a:p>
@@ -8921,7 +8921,7 @@
                   <a:schemeClr val="tx2"/>
                 </a:solidFill>
               </a:rPr>
-              <a:t>Free database limits</a:t>
+              <a:t>No secret in the file</a:t>
             </a:r>
             <a:endParaRPr lang="en-US" sz="1600" dirty="0"/>
           </a:p>
@@ -8957,7 +8957,7 @@
                   <a:schemeClr val="tx1"/>
                 </a:solidFill>
               </a:rPr>
-              <a:t>It holds 1 GB and expires 30 days after it is created.</a:t>
+              <a:t>Render wires DATABASE_URL from the database and generates the secret key.</a:t>
             </a:r>
             <a:endParaRPr lang="en-US" sz="1400" dirty="0"/>
           </a:p>
@@ -9015,7 +9015,7 @@
                   <a:schemeClr val="bg1"/>
                 </a:solidFill>
               </a:rPr>
-              <a:t>Status: prepared with a Blueprint, not deployed yet.</a:t>
+              <a:t>Live until about 24 November 2026: model-review-board-pfo7.onrender.com</a:t>
             </a:r>
             <a:endParaRPr lang="en-US" sz="1400" dirty="0"/>
           </a:p>

</xml_diff>